<commit_message>
docs: update SIH26242 presentation deck with live render platform link and 5 national QPs
</commit_message>
<xml_diff>
--- a/SIH26242-PERCEPTRON-RPL-AI.pptx
+++ b/SIH26242-PERCEPTRON-RPL-AI.pptx
@@ -20648,7 +20648,7 @@
           <a:lstStyle/>
           <a:p>
             <a:r>
-              <a:t>LIVE PLATFORM: pathfinder-rpl.vercel.app / localhost:3000</a:t>
+              <a:t>LIVE PLATFORM: sih-rpl-ai.onrender.com</a:t>
             </a:r>
           </a:p>
         </p:txBody>
@@ -20687,7 +20687,7 @@
           <a:lstStyle/>
           <a:p>
             <a:r>
-              <a:t>TRADES: Automotive (ASC/Q1402) | CNC (CSC/Q0115) | Solar (PSS/Q0101)</a:t>
+              <a:t>5 NATIONAL QPs: Auto (ASC/Q1402) | CNC (CSC/Q0115) | Solar (PSS/Q0101) | Elec (ELE/Q6001) | Weld (CSC/Q0204)</a:t>
             </a:r>
           </a:p>
         </p:txBody>
@@ -20726,7 +20726,7 @@
           <a:lstStyle/>
           <a:p>
             <a:r>
-              <a:t>TEST COVERAGE: 208 Unit &amp; Assessment Tests Passed (Vitest)</a:t>
+              <a:t>TEST COVERAGE: 209 Unit &amp; ML Tests Passed (100% Green Vitest)</a:t>
             </a:r>
           </a:p>
         </p:txBody>

</xml_diff>